<commit_message>
fix(presentation): correct logo frame geometry for cropped srcRect; add render check
</commit_message>
<xml_diff>
--- a/ai_venture_studio_client_presentation.pptx
+++ b/ai_venture_studio_client_presentation.pptx
@@ -4370,7 +4370,7 @@
       <p:grpSpPr/>
       <p:pic>
         <p:nvPicPr>
-          <p:cNvPr id="2" name="Picture 1" descr="logo-full.png"/>
+          <p:cNvPr id="2" name="Picture 1" descr="ai-venture-studio-lockup-880x713.png"/>
           <p:cNvPicPr>
             <a:picLocks noChangeAspect="1"/>
           </p:cNvPicPr>
@@ -4391,15 +4391,14 @@
               </a:clrTo>
             </a:clrChange>
           </a:blip>
-          <a:srcRect l="15152" r="14673" t="18501" b="24641"/>
           <a:stretch>
             <a:fillRect/>
           </a:stretch>
         </p:blipFill>
         <p:spPr>
           <a:xfrm>
-            <a:off x="219248" y="44888"/>
-            <a:ext cx="2475738" cy="2475738"/>
+            <a:off x="594360" y="502920"/>
+            <a:ext cx="1737360" cy="1407656"/>
           </a:xfrm>
           <a:prstGeom prst="rect">
             <a:avLst/>
@@ -8217,7 +8216,7 @@
       </p:sp>
       <p:pic>
         <p:nvPicPr>
-          <p:cNvPr id="4" name="Picture 3" descr="logo-full.png"/>
+          <p:cNvPr id="4" name="Picture 3" descr="ai-venture-studio-lockup-880x713.png"/>
           <p:cNvPicPr>
             <a:picLocks noChangeAspect="1"/>
           </p:cNvPicPr>
@@ -8238,15 +8237,14 @@
               </a:clrTo>
             </a:clrChange>
           </a:blip>
-          <a:srcRect l="15152" r="14673" t="18501" b="24641"/>
           <a:stretch>
             <a:fillRect/>
           </a:stretch>
         </p:blipFill>
         <p:spPr>
           <a:xfrm>
-            <a:off x="3000894" y="3033314"/>
-            <a:ext cx="3127248" cy="3127248"/>
+            <a:off x="3474720" y="3611880"/>
+            <a:ext cx="2194560" cy="1778092"/>
           </a:xfrm>
           <a:prstGeom prst="rect">
             <a:avLst/>

</xml_diff>